<commit_message>
Add complete-syllabus lecture decks: 12 Control Systems and 13 BEEE topics (pptx, pdf, slide tables, index)
Co-Authored-By: Claude Sonnet 5.5 <noreply@anthropic.com>
Claude-Session: https://claude.ai/code/session_01Pes3qCryZz4Pdknw72RX6p
</commit_message>
<xml_diff>
--- a/lecture-decks/BEEE/BEEE_U1b_Sinusoidal_AC_and_Phasors.pptx
+++ b/lecture-decks/BEEE/BEEE_U1b_Sinusoidal_AC_and_Phasors.pptx
@@ -4087,8 +4087,8 @@
         </p:blipFill>
         <p:spPr>
           <a:xfrm>
-            <a:off x="5257800" y="1143000"/>
-            <a:ext cx="3429000" cy="2834640"/>
+            <a:off x="5257800" y="1231583"/>
+            <a:ext cx="3429000" cy="2657475"/>
           </a:xfrm>
           <a:prstGeom prst="rect">
             <a:avLst/>
@@ -4455,8 +4455,8 @@
         </p:blipFill>
         <p:spPr>
           <a:xfrm>
-            <a:off x="5257800" y="1143000"/>
-            <a:ext cx="3429000" cy="2834640"/>
+            <a:off x="5257800" y="1231583"/>
+            <a:ext cx="3429000" cy="2657475"/>
           </a:xfrm>
           <a:prstGeom prst="rect">
             <a:avLst/>

</xml_diff>